<commit_message>
Keep both industrialization numbers on slide 8
60 / 40 is how Diego's time on the floor is split; the supervisor's 90 % is
how ready the MY27 Cummins DOC and DPF program is, with launch planned for
January 2027. The slide now shows each one for what it is.

Co-Authored-By: Claude Opus 5.5 <noreply@anthropic.com>
Claude-Session: https://claude.ai/code/session_012Ye9scek5k3HGgfD9p6dky
</commit_message>
<xml_diff>
--- a/presentations/Tenneco_Robotics_Setter_Diego_de_Leon_V3.pptx
+++ b/presentations/Tenneco_Robotics_Setter_Diego_de_Leon_V3.pptx
@@ -1725,17 +1725,22 @@
           <a:lstStyle/>
           <a:p>
             <a:r>
-              <a:t>• 90% of my time: the MY27 Cummins DOC and DPF program.</a:t>
-            </a:r>
-          </a:p>
-          <a:p>
-            <a:r>
-              <a:t>• Industrialization means getting a new process ready for the floor.</a:t>
-            </a:r>
-          </a:p>
-          <a:p>
-            <a:r>
-              <a:t>• The other 10% at the cells is where most hands-on learning happens.</a:t>
+              <a:t>• Two numbers, not to be mixed up.</a:t>
+            </a:r>
+          </a:p>
+          <a:p>
+            <a:r>
+              <a:t>• 60% of my time goes to industrialization, 40% to support at the cells.</a:t>
+            </a:r>
+          </a:p>
+          <a:p>
+            <a:r>
+              <a:t>• The program itself is 90% ready, with launch planned for January.</a:t>
+            </a:r>
+          </a:p>
+          <a:p>
+            <a:r>
+              <a:t>• The cells are where most of the hands-on learning happens.</a:t>
             </a:r>
           </a:p>
         </p:txBody>
@@ -27751,7 +27756,7 @@
                 </a:solidFill>
                 <a:latin typeface="Segoe UI"/>
               </a:rPr>
-              <a:t>Most of my time goes to industrialization</a:t>
+              <a:t>Most of my time goes to a program that is 90% ready</a:t>
             </a:r>
           </a:p>
         </p:txBody>
@@ -27778,7 +27783,7 @@
                 </a:solidFill>
                 <a:latin typeface="Segoe UI"/>
               </a:rPr>
-              <a:t>How my time is split</a:t>
+              <a:t>My time on the floor, and where the program stands</a:t>
             </a:r>
           </a:p>
         </p:txBody>
@@ -27859,7 +27864,7 @@
                 </a:solidFill>
                 <a:latin typeface="Segoe UI"/>
               </a:rPr>
-              <a:t>90%</a:t>
+              <a:t>60%</a:t>
             </a:r>
             <a:endParaRPr sz="5400" b="1" i="0" dirty="0">
               <a:solidFill>
@@ -27907,7 +27912,7 @@
                 </a:solidFill>
                 <a:latin typeface="Segoe UI"/>
               </a:rPr>
-              <a:t>DOC and DPF program, MY27 Cummins</a:t>
+              <a:t>of my time: industrialization, with Engineering</a:t>
             </a:r>
           </a:p>
         </p:txBody>
@@ -27953,7 +27958,7 @@
         <p:spPr>
           <a:xfrm>
             <a:off x="621792" y="3429000"/>
-            <a:ext cx="3621024" cy="146304"/>
+            <a:ext cx="2414016" cy="146304"/>
           </a:xfrm>
           <a:prstGeom prst="rect">
             <a:avLst/>
@@ -28011,7 +28016,7 @@
                 </a:solidFill>
                 <a:latin typeface="Segoe UI"/>
               </a:rPr>
-              <a:t>10%</a:t>
+              <a:t>40%</a:t>
             </a:r>
           </a:p>
         </p:txBody>
@@ -28148,7 +28153,7 @@
         <p:spPr>
           <a:xfrm>
             <a:off x="5669280" y="2304288"/>
-            <a:ext cx="5897880" cy="487890"/>
+            <a:ext cx="5897880" cy="822960"/>
           </a:xfrm>
           <a:prstGeom prst="rect">
             <a:avLst/>
@@ -28179,7 +28184,7 @@
                 </a:solidFill>
                 <a:latin typeface="Segoe UI"/>
               </a:rPr>
-              <a:t>Industrialization and successful PPAP runs of the MY27 Cummins program, together with Engineering.</a:t>
+              <a:t>Industrialization and successful PPAP runs of the MY27 Cummins DOC and DPF program, together with Engineering.</a:t>
             </a:r>
           </a:p>
         </p:txBody>
@@ -28251,7 +28256,7 @@
                 </a:solidFill>
                 <a:latin typeface="Segoe UI"/>
               </a:rPr>
-              <a:t>WHAT INDUSTRIALIZATION MEANS</a:t>
+              <a:t>PROGRAM PROGRESS</a:t>
             </a:r>
           </a:p>
         </p:txBody>
@@ -28264,8 +28269,8 @@
         </p:nvSpPr>
         <p:spPr>
           <a:xfrm>
-            <a:off x="5669280" y="3950208"/>
-            <a:ext cx="5897880" cy="1188720"/>
+            <a:off x="5669280" y="3913632"/>
+            <a:ext cx="1737360" cy="731520"/>
           </a:xfrm>
           <a:prstGeom prst="rect">
             <a:avLst/>
@@ -28273,15 +28278,12 @@
           <a:noFill/>
         </p:spPr>
         <p:txBody>
-          <a:bodyPr wrap="square" lIns="0" tIns="0" rIns="0" bIns="0" anchor="t">
+          <a:bodyPr wrap="square" lIns="0" rIns="0" tIns="0" bIns="0" anchor="t">
             <a:spAutoFit/>
           </a:bodyPr>
           <a:lstStyle/>
           <a:p>
             <a:pPr algn="l">
-              <a:lnSpc>
-                <a:spcPct val="110000"/>
-              </a:lnSpc>
               <a:spcBef>
                 <a:spcPts val="0"/>
               </a:spcBef>
@@ -28290,14 +28292,135 @@
               </a:spcAft>
             </a:pPr>
             <a:r>
-              <a:rPr sz="1400" b="0" i="0">
-                <a:solidFill>
-                  <a:srgbClr val="C6CDD1"/>
+              <a:rPr sz="4000" b="1" i="0">
+                <a:solidFill>
+                  <a:srgbClr val="D5FB00"/>
                 </a:solidFill>
                 <a:latin typeface="Segoe UI"/>
               </a:rPr>
-              <a:t>Getting a new process ready to run on the floor: equipment, programs, trials and the release to production.</a:t>
-            </a:r>
+              <a:t>90%</a:t>
+            </a:r>
+          </a:p>
+        </p:txBody>
+      </p:sp>
+      <p:sp>
+        <p:nvSpPr>
+          <p:cNvPr id="17" name="TextBox 16"/>
+          <p:cNvSpPr txBox="1"/>
+          <p:nvPr/>
+        </p:nvSpPr>
+        <p:spPr>
+          <a:xfrm>
+            <a:off x="7360920" y="3986784"/>
+            <a:ext cx="4206240" cy="640080"/>
+          </a:xfrm>
+          <a:prstGeom prst="rect">
+            <a:avLst/>
+          </a:prstGeom>
+          <a:noFill/>
+        </p:spPr>
+        <p:txBody>
+          <a:bodyPr wrap="square" lIns="0" rIns="0" tIns="0" bIns="0" anchor="t">
+            <a:spAutoFit/>
+          </a:bodyPr>
+          <a:lstStyle/>
+          <a:p>
+            <a:pPr algn="l">
+              <a:spcBef>
+                <a:spcPts val="0"/>
+              </a:spcBef>
+              <a:spcAft>
+                <a:spcPts val="0"/>
+              </a:spcAft>
+            </a:pPr>
+            <a:r>
+              <a:rPr sz="1400" b="1" i="0">
+                <a:solidFill>
+                  <a:srgbClr val="FFFFFF"/>
+                </a:solidFill>
+                <a:latin typeface="Segoe UI"/>
+              </a:rPr>
+              <a:t>ready to launch</a:t>
+            </a:r>
+          </a:p>
+          <a:p>
+            <a:pPr>
+              <a:spcBef>
+                <a:spcPts val="200"/>
+              </a:spcBef>
+              <a:spcAft>
+                <a:spcPts val="0"/>
+              </a:spcAft>
+            </a:pPr>
+            <a:r>
+              <a:rPr sz="1200" b="0" i="0">
+                <a:solidFill>
+                  <a:srgbClr val="C6CDD1"/>
+                </a:solidFill>
+                <a:latin typeface="Segoe UI"/>
+              </a:rPr>
+              <a:t>Start of production planned for January 2027.</a:t>
+            </a:r>
+          </a:p>
+        </p:txBody>
+      </p:sp>
+      <p:sp>
+        <p:nvSpPr>
+          <p:cNvPr id="18" name="Rectangle 17"/>
+          <p:cNvSpPr/>
+          <p:nvPr/>
+        </p:nvSpPr>
+        <p:spPr>
+          <a:xfrm>
+            <a:off x="5669280" y="4846320"/>
+            <a:ext cx="5897880" cy="146304"/>
+          </a:xfrm>
+          <a:prstGeom prst="rect">
+            <a:avLst/>
+          </a:prstGeom>
+          <a:solidFill>
+            <a:srgbClr val="C6CDD1">
+              <a:alpha val="30000"/>
+            </a:srgbClr>
+          </a:solidFill>
+          <a:ln>
+            <a:noFill/>
+          </a:ln>
+        </p:spPr>
+        <p:txBody>
+          <a:bodyPr rtlCol="0" anchor="ctr" wrap="square" lIns="0" rIns="0" tIns="0" bIns="0"/>
+          <a:lstStyle/>
+          <a:p>
+            <a:pPr algn="ctr"/>
+          </a:p>
+        </p:txBody>
+      </p:sp>
+      <p:sp>
+        <p:nvSpPr>
+          <p:cNvPr id="19" name="Rectangle 18"/>
+          <p:cNvSpPr/>
+          <p:nvPr/>
+        </p:nvSpPr>
+        <p:spPr>
+          <a:xfrm>
+            <a:off x="5669280" y="4846320"/>
+            <a:ext cx="5308092" cy="146304"/>
+          </a:xfrm>
+          <a:prstGeom prst="rect">
+            <a:avLst/>
+          </a:prstGeom>
+          <a:solidFill>
+            <a:srgbClr val="D5FB00"/>
+          </a:solidFill>
+          <a:ln>
+            <a:noFill/>
+          </a:ln>
+        </p:spPr>
+        <p:txBody>
+          <a:bodyPr rtlCol="0" anchor="ctr" wrap="square" lIns="0" rIns="0" tIns="0" bIns="0"/>
+          <a:lstStyle/>
+          <a:p>
+            <a:pPr algn="ctr"/>
           </a:p>
         </p:txBody>
       </p:sp>

</xml_diff>